<commit_message>
docs(demo): spoken script on every deck slide, plus a companion 讲稿 (#2)
Each of the 25 slides now carries the full narration in its speaker notes —
what to say, what to click, how to hand over to the next slide — and the
generator writes the same text as `客户汇报-讲稿.md` beside the deck.

Co-Authored-By: Claude Fable 5.1 <noreply@anthropic.com>
Claude-Session: https://claude.ai/code/session_01FSvGKofkL2VB8DRofKqnX9
</commit_message>
<xml_diff>
--- a/docs/demo/psa-presales/客户汇报-华信案例.pptx
+++ b/docs/demo/psa-presales/客户汇报-华信案例.pptx
@@ -526,7 +526,7 @@
           <a:p>
             <a:r>
               <a:rPr lang="en-US" dirty="0"/>
-              <a:t>开场：贵司给的是一张 40 步、9 个环节的流程表，表里自己就分了两个系统——CRM 和项管平台。今天演示的是这 40 步在同一个平台、同一套数据里跑通的样子。</a:t>
+              <a:t>各位好。今天这场演示不讲产品功能清单，只讲一件事：贵司给我们的那张 40 步、9 个环节的业务流程表，怎样在一个平台、一套数据里从头跑到尾。表里自己就分成了 CRM 和项管平台两个系统，今天大家会看到，它们是同一个系统里的两组对象。下面 40 分钟，我按贵司的流程顺序走，每一步都对应表里的一行。</a:t>
             </a:r>
             <a:endParaRPr lang="en-US" dirty="0"/>
           </a:p>
@@ -614,7 +614,7 @@
           <a:p>
             <a:r>
               <a:rPr lang="en-US" dirty="0"/>
-              <a:t>现场演示：新建商机选中招国际 → 被拒。再把东方联合银行 EAR 改成人工确认 → 被拒；改回机器疑似 → 放行。</a:t>
+              <a:t>这页是两条规则由系统执行的样子。现场演示：新建商机，所属客户选中招国际——招标代理公司——点创建，系统直接拒绝，提示写明「仅可用于付款回款，无法发起商机」。第二条是 EAR：机器比对命中只记为「疑似」，只提示不阻断；把东方联合银行改成「人工确认在列」再建商机，就被拦下。一句话：机器不拦人，人拍板才拦。两条规则读的是客户上的数据，作用在商机上，存量数据不受影响。</a:t>
             </a:r>
             <a:endParaRPr lang="en-US" dirty="0"/>
           </a:p>
@@ -702,7 +702,7 @@
           <a:p>
             <a:r>
               <a:rPr lang="en-US" dirty="0"/>
-              <a:t>演示里七条请求一起批。生产形态：售前立项五级链按组织层级路由，同一个机制。</a:t>
+              <a:t>所有审批的手势都一样。发起：记录页顶部点「发起审批」、确认。处理：我的工作 → 待我审批，勾选，通过 N 条，确认；通过后系统回写状态和审批时间，并通知负责人。转签、退回修改、退回补充、催办、撤回都在同一个面板。今天九条流程——客户、线索、商机立项、售前立项、交付立项、工时、预算调整、出差、请假——全在这一个收件箱里，生产上按贵司组织层级扩成多级。</a:t>
             </a:r>
             <a:endParaRPr lang="en-US" dirty="0"/>
           </a:p>
@@ -790,7 +790,7 @@
           <a:p>
             <a:r>
               <a:rPr lang="en-US" dirty="0"/>
-              <a:t>贵司反馈"审批的发起应该是一个按钮"——已改：按钮 + 只读状态。九个对象同一个机制。</a:t>
+              <a:t>这一页回应贵司上次的反馈：审批的发起应该是一个按钮，而不是编辑记录去改状态。现在每个可审批对象的记录页顶部都有「发起审批」，商机上叫「发起立项审批」；按钮只在草稿或已驳回时出现，点了弹确认框，确认后记录立刻锁定、显示审批中。审批状态和审批通过时间是只读字段——表单里看得到、改不了，只由按钮和审批流来写。驳回后按钮重新出现，改完再发起。</a:t>
             </a:r>
             <a:endParaRPr lang="en-US" dirty="0"/>
           </a:p>
@@ -878,7 +878,7 @@
           <a:p>
             <a:r>
               <a:rPr lang="en-US" dirty="0"/>
-              <a:t>北辰 MES 二期是已成交商机，赢单原因"客户关系"。</a:t>
+              <a:t>步骤 12 到 13。跟进不靠记忆：阶段条直接推进阶段，每次变更自动写进活动时间线；待办任务和活动挂在商机上，右侧任务卡常驻。铁三角——客户经理、解决方案经理、交付经理——三个角色就地调整。赢单、丢单必须填原因。北辰 MES 二期是已成交商机，赢单原因是客户关系。生产形态下铁三角会做成商机团队对象加记录级共享，团队成员自动获得可见性。</a:t>
             </a:r>
             <a:endParaRPr lang="en-US" dirty="0"/>
           </a:p>
@@ -966,7 +966,7 @@
           <a:p>
             <a:r>
               <a:rPr lang="en-US" dirty="0"/>
-              <a:t>改任一项成本，总成本和毛利率当场变——这是公式字段，不是报表。</a:t>
+              <a:t>进入项管平台，步骤 15 到 20。售前项目必须挂在已立项的商机上，选 CRM 商机编码，客户随之带出，编号 PSP。五个角色齐全。四项成本——人工、第三方服务、软硬件采购、项目费用——填完总成本自动算，报价一填毛利率自动算：华信这单 100 万成本、140 万报价、28.57%。现场可以改任一项成本，总成本和毛利率当场变，这是公式字段不是报表。信息安全类别和安全备注在下面。审批通过后才能立交付项目。</a:t>
             </a:r>
             <a:endParaRPr lang="en-US" dirty="0"/>
           </a:p>
@@ -1054,7 +1054,7 @@
           <a:p>
             <a:r>
               <a:rPr lang="en-US" dirty="0"/>
-              <a:t>顶部四个数字：基线、实际成本、预算消耗，都是平台汇总，不用人算。</a:t>
+              <a:t>步骤 21 到 26。交付项目必须选一个已审批的售前项目；预算基线自动取售前 Bizcase 的总成本，同一份 Bizcase 的四项成本还各带一条成本计划行；关联销售合同后合同额自动带出。实施成本中心、核算成本中心、对应部门可以不同——试点项目就是实施华东、核算华北。角色、信息安全、附件都在。顶部的基线、实际成本、预算消耗三个数字是平台汇总的，不用人算。</a:t>
             </a:r>
             <a:endParaRPr lang="en-US" dirty="0"/>
           </a:p>
@@ -1142,7 +1142,7 @@
           <a:p>
             <a:r>
               <a:rPr lang="en-US" dirty="0"/>
-              <a:t>费率卡是主数据：岗位级别 × 小时费率，工时表和成本计划都从这里取价。</a:t>
+              <a:t>步骤 27 到 32。成本计划行按四类成本、按月编制，数量乘单价等于计划金额；人工行选费率卡，单价自动带出。计划总额汇总到交付项目。预算调整是单独的对象：调整金额、原因、差异分析，发起审批；只有已批准的调整才计入「当前预算」。现场演示：追加 15 万通过后，当前预算 100 万变 115 万，预算消耗从 53.4% 降到 46.5%。</a:t>
             </a:r>
             <a:endParaRPr lang="en-US" dirty="0"/>
           </a:p>
@@ -1230,7 +1230,7 @@
           <a:p>
             <a:r>
               <a:rPr lang="en-US" dirty="0"/>
-              <a:t>贵司步骤 33 写的"请假、加班申请同步后自动更新"，就是这条：请假审批过了，工时表自己变。</a:t>
+              <a:t>步骤 33 到 35。工时表选费率卡自动带费率，工时乘费率就是人工成本，还有标准工时、请假工时、加班工时三个数。贵司写的「请假、加班申请同步后自动更新」就是这条：请假审批通过后，申请人当月工时表的请假工时自动变 16，工时 176 变 160，成本重算。出差申请有目的地、起止日期、事由、预计费用，差旅成本关联出差单后自动带出项目、出差人、日期，实际费用汇总回出差单。人工实际成本只计已审批的工时表。</a:t>
             </a:r>
             <a:endParaRPr lang="en-US" dirty="0"/>
           </a:p>
@@ -1318,7 +1318,7 @@
           <a:p>
             <a:r>
               <a:rPr lang="en-US" dirty="0"/>
-              <a:t>两处拦截的截图在下一页；这里先看数字：132%。</a:t>
+              <a:t>步骤 36。系统盯着预算，而不是月底对账：交付项目实时汇总人工实际和差旅实际，得出实际成本、预算消耗、预算差异。试点项目基线 20 万，实际 26.4 万，消耗 132%。对这样的项目，拦截②：新填工时被拒，并把数字写在提示里；拦截④：出差没审批通过，差旅成本登记不了。预算追加走预算调整审批，批准后当前预算上调，填报自动放开。</a:t>
             </a:r>
             <a:endParaRPr lang="en-US" dirty="0"/>
           </a:p>
@@ -1406,7 +1406,7 @@
           <a:p>
             <a:r>
               <a:rPr lang="en-US" dirty="0"/>
-              <a:t>现场演示：工时表新建选试点项目 → 被拒；差旅成本关联草稿出差单 → 被拒。</a:t>
+              <a:t>两张截图就是现场会看到的提示。左边：新建工时表选试点项目，系统写明「实际 264,000 大于等于基线 200,000，工时填报已限制」。右边：差旅成本关联一张草稿出差单，系统提示「尚未审批通过，不能登记差旅成本」。两条提示都是保存那一刻由系统给出的，换一个健康项目或已审批的出差单即可保存。</a:t>
             </a:r>
             <a:endParaRPr lang="en-US" dirty="0"/>
           </a:p>
@@ -1494,7 +1494,7 @@
           <a:p>
             <a:r>
               <a:rPr lang="en-US" dirty="0"/>
-              <a:t>先给结论再看细节：40 步里 39 步今天能点给你看；对象、审批流、拦截的数量说明这是真的系统，不是原型。</a:t>
+              <a:t>先给结论。40 步里 39 步今天能现场点给各位看，只有「商机状态变更审批」这一步留给贵司决策要不要单独审批。为此新建了 14 个业务对象、9 条审批流、4 处系统拦截，全部跑在同一个审批中心里。怎么做到的：不做两套系统再做接口，而是把项目管理长在 CRM 的对象上，商机编码是两侧唯一的锚点；业务规则落在系统里而不是制度里；汇总和公式都是实时算的。演示数据不是四条样例，而是一家软件公司一年的业务面。</a:t>
             </a:r>
             <a:endParaRPr lang="en-US" dirty="0"/>
           </a:p>
@@ -1582,7 +1582,7 @@
           <a:p>
             <a:r>
               <a:rPr lang="en-US" dirty="0"/>
-              <a:t>一期：合同 140 万，已开票 98 万，已收款 42 万，应收 56 万，毛利率 61.8%。</a:t>
+              <a:t>步骤 37、38、40。交付项目的「合同与财务」分组一页看全：销售合同、合同额、项目进度推出已确认收入；已开票、已收款、应收余额；采购合同总额、销售订单总额；项目毛利率。华信一期：合同 140 万，已开票 98 万，已收款 42 万，应收 56 万，毛利率 61.8%。开票、收款、采购合同、销售订单都是独立对象，本阶段手工录入，对接财务、费控、考勤放在后续阶段。</a:t>
             </a:r>
             <a:endParaRPr lang="en-US" dirty="0"/>
           </a:p>
@@ -1670,7 +1670,7 @@
           <a:p>
             <a:r>
               <a:rPr lang="en-US" dirty="0"/>
-              <a:t>两个仪表板都是平台原生的数据集 + 组件，改指标不用写代码。</a:t>
+              <a:t>步骤 37 到 39。交付项目列表切到「项目综合查询」视图：进度、当前预算、实际成本、预算消耗、合同额、已确认收入、开票、收款、应收、毛利率一行看全，可筛选、分组、导出。项目成本仪表板看基线、计划、实际和消耗率；项目财务仪表板看合同额、开票、收款和采购。两个仪表板都是平台原生的数据集加组件，改指标不用写代码。</a:t>
             </a:r>
             <a:endParaRPr lang="en-US" dirty="0"/>
           </a:p>
@@ -1758,7 +1758,7 @@
           <a:p>
             <a:r>
               <a:rPr lang="en-US" dirty="0"/>
-              <a:t>贵司步骤 18 / 28 的"岗位级别、费率标准"就是费率卡；步骤 9 的"软通签约主体"就是签约主体。</a:t>
+              <a:t>贵司步骤 18、28 说的岗位级别和费率标准，就是费率卡：岗位级别乘小时费率、日费率，带生效日期和启用开关，工时表和人工成本计划选了它就自动取价，费率变更集中管理。步骤 9 说的签约主体是我方法人公司的主数据——名称、信用代码、法定代表人、开户行——商机和合同上选择。两者都在导航的「主数据」组，管理员维护，业务人员只选不填。</a:t>
             </a:r>
             <a:endParaRPr lang="en-US" dirty="0"/>
           </a:p>
@@ -1846,7 +1846,7 @@
           <a:p>
             <a:r>
               <a:rPr lang="en-US" dirty="0"/>
-              <a:t>把简化说在前面：审批级数、铁三角共享、三个外部系统对接，都是明确的后续项，不是做不到。</a:t>
+              <a:t>把简化说在前面。售前审批今天一级，生产五级串联、按组织层级自动路由；商机状态变更审批待贵司确认；铁三角做成团队对象加共享；请假同步今天按工作日乘 8 小时算，加班手填，后续对接考勤；报销单据、开票收款后续对接费控和财务。审批发起已经改成按钮加只读状态。演示数据是一家软件公司的样子，上线时换成贵司真实的客户、项目和费率。</a:t>
             </a:r>
             <a:endParaRPr lang="en-US" dirty="0"/>
           </a:p>
@@ -1934,7 +1934,7 @@
           <a:p>
             <a:r>
               <a:rPr lang="en-US" dirty="0"/>
-              <a:t>排期与贵司确认范围后给出。阶段一的前提是五个待答事项。</a:t>
+              <a:t>三个阶段。阶段一试点上线，就是今天演示的范围，前提是贵司确认五个待答事项：跟进记录形态、开票回款归属、线索形态、EAR 判定方式、立项审批与金额审批的关系；然后按组织和岗位配置审批人、权限、费率卡、签约主体，选一个事业部一批真实项目试运行。阶段二做规则和协同：五级审批、状态变更审批、铁三角共享、预算多级审批。阶段三打通考勤、费控、财务三个外部系统。</a:t>
             </a:r>
             <a:endParaRPr lang="en-US" dirty="0"/>
           </a:p>
@@ -2022,7 +2022,7 @@
           <a:p>
             <a:r>
               <a:rPr lang="en-US" dirty="0"/>
-              <a:t>收尾一句话，留下三个动作。</a:t>
+              <a:t>收尾一句话：贵司 40 步流程里，客户、线索、商机、审批中心、附件、跟进、赢丢单是现成的 CRM 能力；售前立项、交付立项、成本计划、工时与差旅、财务与报表这 26 步，是在同一个平台、同一套元数据里长出来的——这也是它能成为软件行业项目型销售标准模板的原因。下一步三个动作：确认五个待答事项，划定试点范围，我们给出排期。谢谢大家，欢迎提问。</a:t>
             </a:r>
             <a:endParaRPr lang="en-US" dirty="0"/>
           </a:p>
@@ -2110,7 +2110,7 @@
           <a:p>
             <a:r>
               <a:rPr lang="en-US" dirty="0"/>
-              <a:t>这页把贵司的表画成图。两种颜色对应表里"系统路径"的两个前缀。强调：26 步在项管侧，靠商机编码挂回 CRM。</a:t>
+              <a:t>这页是把贵司的表画成图：深蓝是 CRM 的 4 个环节 14 步，橙色是项管平台的 5 个环节 26 步。我们读表时发现一件事：26 步在项管侧，但每一步都要读 CRM 里的商机；而 CRM 侧有三条规则其实是跨对象的门禁，不是字段。所以方案不是「两个系统对接」，而是同一个平台上的一组对象——这决定了后面所有设计。</a:t>
             </a:r>
             <a:endParaRPr lang="en-US" dirty="0"/>
           </a:p>
@@ -2198,7 +2198,7 @@
           <a:p>
             <a:r>
               <a:rPr lang="en-US" dirty="0"/>
-              <a:t>三层：平台自带的能力一分钱不用开发；CRM 对象是标准产品加字段；项目对象是本次为贵司流程新建的。都在同一套元数据里。</a:t>
+              <a:t>三层。最上面是平台自带的能力：审批中心、附件、活动时间线、汇总字段、公式字段、权限、仪表板、导入导出、记录锁定——这一层零开发。中间是 CRM 的标准对象加字段：客户、联系人、线索、商机、销售合同，加上签约主体、费率卡两个主数据。底下是本次为贵司流程新建的 12 个项目对象。串起三层的是商机编码：售前项目必须挂在已立项的商机上，交付项目必须挂在已审批的售前项目上，成本、工时、差旅、开票、收款都挂在交付项目下。</a:t>
             </a:r>
             <a:endParaRPr lang="en-US" dirty="0"/>
           </a:p>
@@ -2286,7 +2286,7 @@
           <a:p>
             <a:r>
               <a:rPr lang="en-US" dirty="0"/>
-              <a:t>总览表：逐环节说清做到了什么。两处"待定 / 一级"是刻意留给贵司决策的：状态变更是否单独审批、售前审批走几级。</a:t>
+              <a:t>这张表逐环节说清做到了什么，各位可以对照自己那张表看。绿色是已实现；两处橙色是刻意留给贵司决策的：商机状态变更要不要单独走审批，售前审批今天演示的是一级、生产上走五级。项目报表环节的开票、收款目前是手工录入，对接财务系统放在后续阶段。接下来按环节一个个看。</a:t>
             </a:r>
             <a:endParaRPr lang="en-US" dirty="0"/>
           </a:p>
@@ -2374,7 +2374,7 @@
           <a:p>
             <a:r>
               <a:rPr lang="en-US" dirty="0"/>
-              <a:t>数据不是四条样例，而是一家软件公司一年的业务面：所有列表、仪表板、报表都有数。演示时可以随手点开任何一条。</a:t>
+              <a:t>演示环境里是一家叫华软股份的软件公司一年的业务：14 家客户横跨制造、金融、医药、物流、能源、教育；14 条线索从新建到未通过都有；13 个商机每个阶段都有，5 赢 1 丢；6 份合同、8 个售前 Bizcase、7 个交付项目，以及它们的成本计划、工时、出差、请假、开票、收款。意思是各位待会儿看到的每张列表、每个仪表板都有数，讲到哪里都可以随手点开。</a:t>
             </a:r>
             <a:endParaRPr lang="en-US" dirty="0"/>
           </a:p>
@@ -2462,7 +2462,7 @@
           <a:p>
             <a:r>
               <a:rPr lang="en-US" dirty="0"/>
-              <a:t>两张图都是平台原生数据集 + 组件；数据一多，仪表板自然就成型。</a:t>
+              <a:t>数据一多，仪表板自然就成型。左边是标准的销售业绩仪表板：本季度已成交 715 万、赢率 83%、阶段分布、月度收入趋势——这些都是平台原生的，数据一到就有。右边是交付项目列表，健康度一眼看出：北辰二期消耗 47%、长江 DMS 刚开始 17%、天启 TMS 已关闭 87%，华信数据中台 132% 是超支的那个，后面成本管控环节会用到它。</a:t>
             </a:r>
             <a:endParaRPr lang="en-US" dirty="0"/>
           </a:p>
@@ -2550,7 +2550,7 @@
           <a:p>
             <a:r>
               <a:rPr lang="en-US" dirty="0"/>
-              <a:t>打开华信科技：分类、简称、信用代码在基本信息；业务信息分组里有 EAR 四态。招标代理客户后面会被拦下。</a:t>
+              <a:t>进入第一个环节，步骤 1 到 5。此时切到系统，打开华信科技这家客户。客户编码自动分配；基本信息里有贵司要的客户分类、客户简称、统一社会信用代码。往下是业务信息分组：当前主要服务商、本年度 IT 采购预算、付款周期、美国 EAR 管制清单、战略合作伙伴。联系人多了性别、角色、态度、关系强度四个字段。附件页签直接拖资料进来。客户提交审批后记录锁定，通过后才正式生效——审批怎么发起，第 12 页专门讲。</a:t>
             </a:r>
             <a:endParaRPr lang="en-US" dirty="0"/>
           </a:p>
@@ -2638,7 +2638,7 @@
           <a:p>
             <a:r>
               <a:rPr lang="en-US" dirty="0"/>
-              <a:t>线索是"需求形"的：金额和需求类型是贵司要的。商机上的编码是后面售前立项要选的那个"CRM 商机编码"。</a:t>
+              <a:t>步骤 6 到 11。线索是「需求形」的：预计金额、需求类型是贵司要的，审批通过后才转商机。商机上最重要的是 OPP 编码——它是项管平台关联的锚点。跟单信息里有是否投标、级别、优先级、可控性、客户立项时间、预计招标时间、分包信息；签约主体是独立主数据，业务分类、收入确认类型都在。客户简介、项目背景、风险、付款条款按结构写在背景说明里。立项审批独立于标准产品按金额分档的审批。</a:t>
             </a:r>
             <a:endParaRPr lang="en-US" dirty="0"/>
           </a:p>

</xml_diff>